<commit_message>
Clean repo: untrack scripts, build artifacts, and DB files; keep PPT and docs
</commit_message>
<xml_diff>
--- a/AI-Ticket-Agent-Project-Deck.pptx
+++ b/AI-Ticket-Agent-Project-Deck.pptx
@@ -3293,7 +3293,7 @@
                 </a:solidFill>
                 <a:latin typeface="Segoe UI"/>
               </a:rPr>
-              <a:t>AI-POWERED INTERNAL SUPPORT</a:t>
+              <a:t>AI-POWERED TICKET AGENT</a:t>
             </a:r>
           </a:p>
         </p:txBody>
@@ -3479,7 +3479,7 @@
                 </a:solidFill>
                 <a:latin typeface="Segoe UI"/>
               </a:rPr>
-              <a:t>IntelliTriage • AI-Powered Internal Ticketing</a:t>
+              <a:t>IntelliTriage • AI-Powered Ticket Agent</a:t>
             </a:r>
           </a:p>
         </p:txBody>
@@ -4538,7 +4538,7 @@
                 </a:solidFill>
                 <a:latin typeface="Segoe UI"/>
               </a:rPr>
-              <a:t>IntelliTriage • AI-Powered Internal Ticketing</a:t>
+              <a:t>IntelliTriage • AI-Powered Ticket Agent</a:t>
             </a:r>
           </a:p>
         </p:txBody>
@@ -5122,7 +5122,7 @@
                 </a:solidFill>
                 <a:latin typeface="Segoe UI"/>
               </a:rPr>
-              <a:t>IntelliTriage • AI-Powered Internal Ticketing</a:t>
+              <a:t>IntelliTriage • AI-Powered Ticket Agent</a:t>
             </a:r>
           </a:p>
         </p:txBody>
@@ -6151,7 +6151,7 @@
                 </a:solidFill>
                 <a:latin typeface="Segoe UI"/>
               </a:rPr>
-              <a:t>IntelliTriage • AI-Powered Internal Ticketing</a:t>
+              <a:t>IntelliTriage • AI-Powered Ticket Agent</a:t>
             </a:r>
           </a:p>
         </p:txBody>
@@ -7926,7 +7926,7 @@
                 </a:solidFill>
                 <a:latin typeface="Segoe UI"/>
               </a:rPr>
-              <a:t>IntelliTriage • AI-Powered Internal Ticketing</a:t>
+              <a:t>IntelliTriage • AI-Powered Ticket Agent</a:t>
             </a:r>
           </a:p>
         </p:txBody>
@@ -9673,7 +9673,7 @@
                 </a:solidFill>
                 <a:latin typeface="Segoe UI"/>
               </a:rPr>
-              <a:t>IntelliTriage • AI-Powered Internal Ticketing</a:t>
+              <a:t>IntelliTriage • AI-Powered Ticket Agent</a:t>
             </a:r>
           </a:p>
         </p:txBody>
@@ -11192,7 +11192,7 @@
                 </a:solidFill>
                 <a:latin typeface="Segoe UI"/>
               </a:rPr>
-              <a:t>IntelliTriage • AI-Powered Internal Ticketing</a:t>
+              <a:t>IntelliTriage • AI-Powered Ticket Agent</a:t>
             </a:r>
           </a:p>
         </p:txBody>
@@ -12227,7 +12227,7 @@
                 </a:solidFill>
                 <a:latin typeface="Segoe UI"/>
               </a:rPr>
-              <a:t>IntelliTriage • AI-Powered Internal Ticketing</a:t>
+              <a:t>IntelliTriage • AI-Powered Ticket Agent</a:t>
             </a:r>
           </a:p>
         </p:txBody>
@@ -13442,7 +13442,7 @@
                 </a:solidFill>
                 <a:latin typeface="Segoe UI"/>
               </a:rPr>
-              <a:t>IntelliTriage • AI-Powered Internal Ticketing</a:t>
+              <a:t>IntelliTriage • AI-Powered Ticket Agent</a:t>
             </a:r>
           </a:p>
         </p:txBody>
@@ -15061,7 +15061,7 @@
                 </a:solidFill>
                 <a:latin typeface="Segoe UI"/>
               </a:rPr>
-              <a:t>IntelliTriage • AI-Powered Internal Ticketing</a:t>
+              <a:t>IntelliTriage • AI-Powered Ticket Agent</a:t>
             </a:r>
           </a:p>
         </p:txBody>
@@ -16356,7 +16356,7 @@
                 </a:solidFill>
                 <a:latin typeface="Segoe UI"/>
               </a:rPr>
-              <a:t>IntelliTriage • AI-Powered Internal Ticketing</a:t>
+              <a:t>IntelliTriage • AI-Powered Ticket Agent</a:t>
             </a:r>
           </a:p>
         </p:txBody>

</xml_diff>